<commit_message>
fix: voice-claude-look checks every background; night ink; exact fonts (FX-7, B-9, B-11)
B-9 (Q-34 overruled): voice-claude-look now tests every palette role a
system surface uses as a background (Swiss: paper and ink, the section
surface), and night's ink becomes ECECEC (C* 0.00; ink/paper and
paper/ink 15.06, accent_on_ink/ink 5.02), so no stock voice has a
voice-* finding. B-11: off-pack-font compares family names exactly,
after casefold and whitespace collapse; A-8's weight stripping had let
"Arial Black" and "Arial Narrow" pass as Arial. font-count keeps A-8.

Fixtures changed by the rulings: off-pack-font--pos gains Arial Black
and Arial Narrow; off-pack-font--neg drops "Arial Bold" (now a finding)
for a loosely spelled "  ARIAL "; pack-voice-night is rebuilt with the
new ink. Tests: the B-8.10 table with B-9's night values; a cream ink
fires; exact font names.

Co-Authored-By: Claude Opus 5.5 (1M context) <noreply@anthropic.com>
</commit_message>
<xml_diff>
--- a/fixtures/rules/off-pack-font--neg.pptx
+++ b/fixtures/rules/off-pack-font--neg.pptx
@@ -2545,7 +2545,7 @@
       </p:sp>
       <p:sp>
         <p:nvSpPr>
-          <p:cNvPr id="5" name="bold"/>
+          <p:cNvPr id="5" name="loose"/>
           <p:cNvSpPr txBox="1"/>
           <p:nvPr/>
         </p:nvSpPr>
@@ -2570,9 +2570,9 @@
                 <a:solidFill>
                   <a:srgbClr val="111111"/>
                 </a:solidFill>
-                <a:latin typeface="Arial Bold"/>
+                <a:latin typeface="  ARIAL "/>
               </a:rPr>
-              <a:t>Arial Bold is Arial</a:t>
+              <a:t>Spelled loosely</a:t>
             </a:r>
           </a:p>
         </p:txBody>

</xml_diff>